<commit_message>
Final touches on the ppt
</commit_message>
<xml_diff>
--- a/HaladoC#Demo.pptx
+++ b/HaladoC#Demo.pptx
@@ -264,7 +264,7 @@
           <a:p>
             <a:fld id="{FB5A2253-BBB7-4B79-BA99-3A2583E1B15B}" type="datetimeFigureOut">
               <a:rPr lang="hu-HU" smtClean="0"/>
-              <a:t>2026. 04. 28.</a:t>
+              <a:t>2026. 05. 04.</a:t>
             </a:fld>
             <a:endParaRPr lang="hu-HU"/>
           </a:p>
@@ -462,7 +462,7 @@
           <a:p>
             <a:fld id="{FB5A2253-BBB7-4B79-BA99-3A2583E1B15B}" type="datetimeFigureOut">
               <a:rPr lang="hu-HU" smtClean="0"/>
-              <a:t>2026. 04. 28.</a:t>
+              <a:t>2026. 05. 04.</a:t>
             </a:fld>
             <a:endParaRPr lang="hu-HU"/>
           </a:p>
@@ -670,7 +670,7 @@
           <a:p>
             <a:fld id="{FB5A2253-BBB7-4B79-BA99-3A2583E1B15B}" type="datetimeFigureOut">
               <a:rPr lang="hu-HU" smtClean="0"/>
-              <a:t>2026. 04. 28.</a:t>
+              <a:t>2026. 05. 04.</a:t>
             </a:fld>
             <a:endParaRPr lang="hu-HU"/>
           </a:p>
@@ -868,7 +868,7 @@
           <a:p>
             <a:fld id="{FB5A2253-BBB7-4B79-BA99-3A2583E1B15B}" type="datetimeFigureOut">
               <a:rPr lang="hu-HU" smtClean="0"/>
-              <a:t>2026. 04. 28.</a:t>
+              <a:t>2026. 05. 04.</a:t>
             </a:fld>
             <a:endParaRPr lang="hu-HU"/>
           </a:p>
@@ -1143,7 +1143,7 @@
           <a:p>
             <a:fld id="{FB5A2253-BBB7-4B79-BA99-3A2583E1B15B}" type="datetimeFigureOut">
               <a:rPr lang="hu-HU" smtClean="0"/>
-              <a:t>2026. 04. 28.</a:t>
+              <a:t>2026. 05. 04.</a:t>
             </a:fld>
             <a:endParaRPr lang="hu-HU"/>
           </a:p>
@@ -1408,7 +1408,7 @@
           <a:p>
             <a:fld id="{FB5A2253-BBB7-4B79-BA99-3A2583E1B15B}" type="datetimeFigureOut">
               <a:rPr lang="hu-HU" smtClean="0"/>
-              <a:t>2026. 04. 28.</a:t>
+              <a:t>2026. 05. 04.</a:t>
             </a:fld>
             <a:endParaRPr lang="hu-HU"/>
           </a:p>
@@ -1820,7 +1820,7 @@
           <a:p>
             <a:fld id="{FB5A2253-BBB7-4B79-BA99-3A2583E1B15B}" type="datetimeFigureOut">
               <a:rPr lang="hu-HU" smtClean="0"/>
-              <a:t>2026. 04. 28.</a:t>
+              <a:t>2026. 05. 04.</a:t>
             </a:fld>
             <a:endParaRPr lang="hu-HU"/>
           </a:p>
@@ -1961,7 +1961,7 @@
           <a:p>
             <a:fld id="{FB5A2253-BBB7-4B79-BA99-3A2583E1B15B}" type="datetimeFigureOut">
               <a:rPr lang="hu-HU" smtClean="0"/>
-              <a:t>2026. 04. 28.</a:t>
+              <a:t>2026. 05. 04.</a:t>
             </a:fld>
             <a:endParaRPr lang="hu-HU"/>
           </a:p>
@@ -2074,7 +2074,7 @@
           <a:p>
             <a:fld id="{FB5A2253-BBB7-4B79-BA99-3A2583E1B15B}" type="datetimeFigureOut">
               <a:rPr lang="hu-HU" smtClean="0"/>
-              <a:t>2026. 04. 28.</a:t>
+              <a:t>2026. 05. 04.</a:t>
             </a:fld>
             <a:endParaRPr lang="hu-HU"/>
           </a:p>
@@ -2385,7 +2385,7 @@
           <a:p>
             <a:fld id="{FB5A2253-BBB7-4B79-BA99-3A2583E1B15B}" type="datetimeFigureOut">
               <a:rPr lang="hu-HU" smtClean="0"/>
-              <a:t>2026. 04. 28.</a:t>
+              <a:t>2026. 05. 04.</a:t>
             </a:fld>
             <a:endParaRPr lang="hu-HU"/>
           </a:p>
@@ -2673,7 +2673,7 @@
           <a:p>
             <a:fld id="{FB5A2253-BBB7-4B79-BA99-3A2583E1B15B}" type="datetimeFigureOut">
               <a:rPr lang="hu-HU" smtClean="0"/>
-              <a:t>2026. 04. 28.</a:t>
+              <a:t>2026. 05. 04.</a:t>
             </a:fld>
             <a:endParaRPr lang="hu-HU"/>
           </a:p>
@@ -2914,7 +2914,7 @@
           <a:p>
             <a:fld id="{FB5A2253-BBB7-4B79-BA99-3A2583E1B15B}" type="datetimeFigureOut">
               <a:rPr lang="hu-HU" smtClean="0"/>
-              <a:t>2026. 04. 28.</a:t>
+              <a:t>2026. 05. 04.</a:t>
             </a:fld>
             <a:endParaRPr lang="hu-HU"/>
           </a:p>
@@ -3742,6 +3742,9 @@
   <p:clrMapOvr>
     <a:masterClrMapping/>
   </p:clrMapOvr>
+  <p:transition spd="slow">
+    <p:wipe/>
+  </p:transition>
   <p:timing>
     <p:tnLst>
       <p:par>
@@ -4649,6 +4652,9 @@
   <p:clrMapOvr>
     <a:masterClrMapping/>
   </p:clrMapOvr>
+  <p:transition spd="slow">
+    <p:wipe/>
+  </p:transition>
   <p:timing>
     <p:tnLst>
       <p:par>
@@ -5036,16 +5042,13 @@
                   <a:schemeClr val="bg1"/>
                 </a:solidFill>
               </a:rPr>
-              <a:t>Képernyő méret és</a:t>
-            </a:r>
-            <a:r>
-              <a:rPr lang="hu-HU" dirty="0">
-                <a:solidFill>
-                  <a:schemeClr val="bg1"/>
-                </a:solidFill>
-              </a:rPr>
-              <a:t> nagyítás alapján állítani a minimum ablakméretet</a:t>
-            </a:r>
+              <a:t>Menü ablakának módosítása</a:t>
+            </a:r>
+            <a:endParaRPr lang="hu-HU" dirty="0">
+              <a:solidFill>
+                <a:schemeClr val="bg1"/>
+              </a:solidFill>
+            </a:endParaRPr>
           </a:p>
           <a:p>
             <a:r>
@@ -5097,6 +5100,283 @@
   <p:clrMapOvr>
     <a:masterClrMapping/>
   </p:clrMapOvr>
+  <p:transition spd="slow">
+    <p:wipe/>
+  </p:transition>
+  <p:timing>
+    <p:tnLst>
+      <p:par>
+        <p:cTn id="1" dur="indefinite" restart="never" nodeType="tmRoot">
+          <p:childTnLst>
+            <p:seq concurrent="1" nextAc="seek">
+              <p:cTn id="2" dur="indefinite" nodeType="mainSeq">
+                <p:childTnLst>
+                  <p:par>
+                    <p:cTn id="3" fill="hold">
+                      <p:stCondLst>
+                        <p:cond delay="indefinite"/>
+                      </p:stCondLst>
+                      <p:childTnLst>
+                        <p:par>
+                          <p:cTn id="4" fill="hold">
+                            <p:stCondLst>
+                              <p:cond delay="0"/>
+                            </p:stCondLst>
+                            <p:childTnLst>
+                              <p:par>
+                                <p:cTn id="5" presetID="10" presetClass="entr" presetSubtype="0" fill="hold" nodeType="clickEffect">
+                                  <p:stCondLst>
+                                    <p:cond delay="0"/>
+                                  </p:stCondLst>
+                                  <p:childTnLst>
+                                    <p:set>
+                                      <p:cBhvr>
+                                        <p:cTn id="6" dur="1" fill="hold">
+                                          <p:stCondLst>
+                                            <p:cond delay="0"/>
+                                          </p:stCondLst>
+                                        </p:cTn>
+                                        <p:tgtEl>
+                                          <p:spTgt spid="4">
+                                            <p:txEl>
+                                              <p:pRg st="0" end="0"/>
+                                            </p:txEl>
+                                          </p:spTgt>
+                                        </p:tgtEl>
+                                        <p:attrNameLst>
+                                          <p:attrName>style.visibility</p:attrName>
+                                        </p:attrNameLst>
+                                      </p:cBhvr>
+                                      <p:to>
+                                        <p:strVal val="visible"/>
+                                      </p:to>
+                                    </p:set>
+                                    <p:animEffect transition="in" filter="fade">
+                                      <p:cBhvr>
+                                        <p:cTn id="7" dur="500"/>
+                                        <p:tgtEl>
+                                          <p:spTgt spid="4">
+                                            <p:txEl>
+                                              <p:pRg st="0" end="0"/>
+                                            </p:txEl>
+                                          </p:spTgt>
+                                        </p:tgtEl>
+                                      </p:cBhvr>
+                                    </p:animEffect>
+                                  </p:childTnLst>
+                                </p:cTn>
+                              </p:par>
+                            </p:childTnLst>
+                          </p:cTn>
+                        </p:par>
+                      </p:childTnLst>
+                    </p:cTn>
+                  </p:par>
+                  <p:par>
+                    <p:cTn id="8" fill="hold">
+                      <p:stCondLst>
+                        <p:cond delay="indefinite"/>
+                      </p:stCondLst>
+                      <p:childTnLst>
+                        <p:par>
+                          <p:cTn id="9" fill="hold">
+                            <p:stCondLst>
+                              <p:cond delay="0"/>
+                            </p:stCondLst>
+                            <p:childTnLst>
+                              <p:par>
+                                <p:cTn id="10" presetID="10" presetClass="entr" presetSubtype="0" fill="hold" nodeType="clickEffect">
+                                  <p:stCondLst>
+                                    <p:cond delay="0"/>
+                                  </p:stCondLst>
+                                  <p:childTnLst>
+                                    <p:set>
+                                      <p:cBhvr>
+                                        <p:cTn id="11" dur="1" fill="hold">
+                                          <p:stCondLst>
+                                            <p:cond delay="0"/>
+                                          </p:stCondLst>
+                                        </p:cTn>
+                                        <p:tgtEl>
+                                          <p:spTgt spid="4">
+                                            <p:txEl>
+                                              <p:pRg st="1" end="1"/>
+                                            </p:txEl>
+                                          </p:spTgt>
+                                        </p:tgtEl>
+                                        <p:attrNameLst>
+                                          <p:attrName>style.visibility</p:attrName>
+                                        </p:attrNameLst>
+                                      </p:cBhvr>
+                                      <p:to>
+                                        <p:strVal val="visible"/>
+                                      </p:to>
+                                    </p:set>
+                                    <p:animEffect transition="in" filter="fade">
+                                      <p:cBhvr>
+                                        <p:cTn id="12" dur="500"/>
+                                        <p:tgtEl>
+                                          <p:spTgt spid="4">
+                                            <p:txEl>
+                                              <p:pRg st="1" end="1"/>
+                                            </p:txEl>
+                                          </p:spTgt>
+                                        </p:tgtEl>
+                                      </p:cBhvr>
+                                    </p:animEffect>
+                                  </p:childTnLst>
+                                </p:cTn>
+                              </p:par>
+                            </p:childTnLst>
+                          </p:cTn>
+                        </p:par>
+                      </p:childTnLst>
+                    </p:cTn>
+                  </p:par>
+                  <p:par>
+                    <p:cTn id="13" fill="hold">
+                      <p:stCondLst>
+                        <p:cond delay="indefinite"/>
+                      </p:stCondLst>
+                      <p:childTnLst>
+                        <p:par>
+                          <p:cTn id="14" fill="hold">
+                            <p:stCondLst>
+                              <p:cond delay="0"/>
+                            </p:stCondLst>
+                            <p:childTnLst>
+                              <p:par>
+                                <p:cTn id="15" presetID="10" presetClass="entr" presetSubtype="0" fill="hold" nodeType="clickEffect">
+                                  <p:stCondLst>
+                                    <p:cond delay="0"/>
+                                  </p:stCondLst>
+                                  <p:childTnLst>
+                                    <p:set>
+                                      <p:cBhvr>
+                                        <p:cTn id="16" dur="1" fill="hold">
+                                          <p:stCondLst>
+                                            <p:cond delay="0"/>
+                                          </p:stCondLst>
+                                        </p:cTn>
+                                        <p:tgtEl>
+                                          <p:spTgt spid="4">
+                                            <p:txEl>
+                                              <p:pRg st="2" end="2"/>
+                                            </p:txEl>
+                                          </p:spTgt>
+                                        </p:tgtEl>
+                                        <p:attrNameLst>
+                                          <p:attrName>style.visibility</p:attrName>
+                                        </p:attrNameLst>
+                                      </p:cBhvr>
+                                      <p:to>
+                                        <p:strVal val="visible"/>
+                                      </p:to>
+                                    </p:set>
+                                    <p:animEffect transition="in" filter="fade">
+                                      <p:cBhvr>
+                                        <p:cTn id="17" dur="500"/>
+                                        <p:tgtEl>
+                                          <p:spTgt spid="4">
+                                            <p:txEl>
+                                              <p:pRg st="2" end="2"/>
+                                            </p:txEl>
+                                          </p:spTgt>
+                                        </p:tgtEl>
+                                      </p:cBhvr>
+                                    </p:animEffect>
+                                  </p:childTnLst>
+                                </p:cTn>
+                              </p:par>
+                            </p:childTnLst>
+                          </p:cTn>
+                        </p:par>
+                      </p:childTnLst>
+                    </p:cTn>
+                  </p:par>
+                  <p:par>
+                    <p:cTn id="18" fill="hold">
+                      <p:stCondLst>
+                        <p:cond delay="indefinite"/>
+                      </p:stCondLst>
+                      <p:childTnLst>
+                        <p:par>
+                          <p:cTn id="19" fill="hold">
+                            <p:stCondLst>
+                              <p:cond delay="0"/>
+                            </p:stCondLst>
+                            <p:childTnLst>
+                              <p:par>
+                                <p:cTn id="20" presetID="10" presetClass="entr" presetSubtype="0" fill="hold" nodeType="clickEffect">
+                                  <p:stCondLst>
+                                    <p:cond delay="0"/>
+                                  </p:stCondLst>
+                                  <p:childTnLst>
+                                    <p:set>
+                                      <p:cBhvr>
+                                        <p:cTn id="21" dur="1" fill="hold">
+                                          <p:stCondLst>
+                                            <p:cond delay="0"/>
+                                          </p:stCondLst>
+                                        </p:cTn>
+                                        <p:tgtEl>
+                                          <p:spTgt spid="4">
+                                            <p:txEl>
+                                              <p:pRg st="3" end="3"/>
+                                            </p:txEl>
+                                          </p:spTgt>
+                                        </p:tgtEl>
+                                        <p:attrNameLst>
+                                          <p:attrName>style.visibility</p:attrName>
+                                        </p:attrNameLst>
+                                      </p:cBhvr>
+                                      <p:to>
+                                        <p:strVal val="visible"/>
+                                      </p:to>
+                                    </p:set>
+                                    <p:animEffect transition="in" filter="fade">
+                                      <p:cBhvr>
+                                        <p:cTn id="22" dur="500"/>
+                                        <p:tgtEl>
+                                          <p:spTgt spid="4">
+                                            <p:txEl>
+                                              <p:pRg st="3" end="3"/>
+                                            </p:txEl>
+                                          </p:spTgt>
+                                        </p:tgtEl>
+                                      </p:cBhvr>
+                                    </p:animEffect>
+                                  </p:childTnLst>
+                                </p:cTn>
+                              </p:par>
+                            </p:childTnLst>
+                          </p:cTn>
+                        </p:par>
+                      </p:childTnLst>
+                    </p:cTn>
+                  </p:par>
+                </p:childTnLst>
+              </p:cTn>
+              <p:prevCondLst>
+                <p:cond evt="onPrev" delay="0">
+                  <p:tgtEl>
+                    <p:sldTgt/>
+                  </p:tgtEl>
+                </p:cond>
+              </p:prevCondLst>
+              <p:nextCondLst>
+                <p:cond evt="onNext" delay="0">
+                  <p:tgtEl>
+                    <p:sldTgt/>
+                  </p:tgtEl>
+                </p:cond>
+              </p:nextCondLst>
+            </p:seq>
+          </p:childTnLst>
+        </p:cTn>
+      </p:par>
+    </p:tnLst>
+  </p:timing>
 </p:sld>
 </file>
 
@@ -5198,6 +5478,9 @@
   <p:clrMapOvr>
     <a:masterClrMapping/>
   </p:clrMapOvr>
+  <p:transition spd="slow">
+    <p:wipe/>
+  </p:transition>
 </p:sld>
 </file>
 
@@ -5307,6 +5590,9 @@
   <p:clrMapOvr>
     <a:masterClrMapping/>
   </p:clrMapOvr>
+  <p:transition spd="slow">
+    <p:wipe/>
+  </p:transition>
 </p:sld>
 </file>
 

</xml_diff>